<commit_message>
Ep1: policies vs guardrails slide
</commit_message>
<xml_diff>
--- a/episodes/01-what-is-an-agent/slides/ep01-what-is-an-agent.pptx
+++ b/episodes/01-what-is-an-agent/slides/ep01-what-is-an-agent.pptx
@@ -19,9 +19,10 @@
     <p:sldId id="267" r:id="rId13"/>
     <p:sldId id="268" r:id="rId14"/>
     <p:sldId id="269" r:id="rId15"/>
+    <p:sldId id="270" r:id="rId16"/>
   </p:sldIdLst>
   <p:notesMasterIdLst>
-    <p:notesMasterId r:id="rId16"/>
+    <p:notesMasterId r:id="rId17"/>
   </p:notesMasterIdLst>
   <p:sldSz cx="9144000" cy="5143500"/>
   <p:notesSz cx="5143500" cy="9144000"/>
@@ -955,7 +956,7 @@
           <a:p>
             <a:r>
               <a:rPr lang="en-US" dirty="0"/>
-              <a:t>Recap in 30 seconds, then the call to action: next episode we build the first agent live, inside the ERP.</a:t>
+              <a:t>Policies are the rules about what the agent MAY do, written by the business. Guardrails are the mechanisms that enforce them whatever the model decides. A policy in the system prompt is a request; a guardrail in code is a guarantee. The model can be wrong, misled by an injected instruction in a customer message, or drift between versions — so every policy that matters gets a guardrail too. Walk the five layers. Then point out that Episode 2's agent already has four of them without naming them: check_return_policy encodes the thresholds, request_approval is the human gate, MAX_STEPS is a runtime cap, qty-over-sold is a tool guardrail. Input and output checks are the gap Episode 25 fills.</a:t>
             </a:r>
             <a:endParaRPr lang="en-US" dirty="0"/>
           </a:p>
@@ -979,6 +980,94 @@
             <a:fld id="{F7021451-1387-4CA6-816F-3879F97B5CBC}" type="slidenum">
               <a:rPr lang="en-US"/>
               <a:t>14</a:t>
+            </a:fld>
+            <a:endParaRPr lang="en-US"/>
+          </a:p>
+        </p:txBody>
+      </p:sp>
+    </p:spTree>
+    <p:extLst>
+      <p:ext uri="{BB962C8B-B14F-4D97-AF65-F5344CB8AC3E}">
+        <p14:creationId xmlns:p14="http://schemas.microsoft.com/office/powerpoint/2010/main" val="1024086991"/>
+      </p:ext>
+    </p:extLst>
+  </p:cSld>
+  <p:clrMapOvr>
+    <a:masterClrMapping/>
+  </p:clrMapOvr>
+</p:notes>
+</file>
+
+<file path=ppt/notesSlides/notesSlide15.xml><?xml version="1.0" encoding="utf-8"?>
+<p:notes xmlns:a="http://schemas.openxmlformats.org/drawingml/2006/main" xmlns:r="http://schemas.openxmlformats.org/officeDocument/2006/relationships" xmlns:p="http://schemas.openxmlformats.org/presentationml/2006/main">
+  <p:cSld>
+    <p:spTree>
+      <p:nvGrpSpPr>
+        <p:cNvPr id="1" name=""/>
+        <p:cNvGrpSpPr/>
+        <p:nvPr/>
+      </p:nvGrpSpPr>
+      <p:grpSpPr>
+        <a:xfrm>
+          <a:off x="0" y="0"/>
+          <a:ext cx="0" cy="0"/>
+          <a:chOff x="0" y="0"/>
+          <a:chExt cx="0" cy="0"/>
+        </a:xfrm>
+      </p:grpSpPr>
+      <p:sp>
+        <p:nvSpPr>
+          <p:cNvPr id="2" name="Slide Image Placeholder 1"/>
+          <p:cNvSpPr>
+            <a:spLocks noGrp="1" noRot="1" noChangeAspect="1"/>
+          </p:cNvSpPr>
+          <p:nvPr>
+            <p:ph type="sldImg"/>
+          </p:nvPr>
+        </p:nvSpPr>
+        <p:spPr/>
+      </p:sp>
+      <p:sp>
+        <p:nvSpPr>
+          <p:cNvPr id="3" name="Notes Placeholder 2"/>
+          <p:cNvSpPr>
+            <a:spLocks noGrp="1"/>
+          </p:cNvSpPr>
+          <p:nvPr>
+            <p:ph type="body" idx="1"/>
+          </p:nvPr>
+        </p:nvSpPr>
+        <p:spPr/>
+        <p:txBody>
+          <a:bodyPr/>
+          <a:lstStyle/>
+          <a:p>
+            <a:r>
+              <a:rPr lang="en-US" dirty="0"/>
+              <a:t>Recap in 30 seconds, then the call to action: next episode we build the first agent live, inside the ERP.</a:t>
+            </a:r>
+            <a:endParaRPr lang="en-US" dirty="0"/>
+          </a:p>
+        </p:txBody>
+      </p:sp>
+      <p:sp>
+        <p:nvSpPr>
+          <p:cNvPr id="4" name="Slide Number Placeholder 3"/>
+          <p:cNvSpPr>
+            <a:spLocks noGrp="1"/>
+          </p:cNvSpPr>
+          <p:nvPr>
+            <p:ph type="sldNum" sz="quarter" idx="10"/>
+          </p:nvPr>
+        </p:nvSpPr>
+        <p:spPr/>
+        <p:txBody>
+          <a:bodyPr/>
+          <a:lstStyle/>
+          <a:p>
+            <a:fld id="{F7021451-1387-4CA6-816F-3879F97B5CBC}" type="slidenum">
+              <a:rPr lang="en-US"/>
+              <a:t>15</a:t>
             </a:fld>
             <a:endParaRPr lang="en-US"/>
           </a:p>
@@ -6941,6 +7030,1361 @@
         </p:nvSpPr>
         <p:spPr>
           <a:xfrm>
+            <a:off x="457200" y="274320"/>
+            <a:ext cx="8229600" cy="248920"/>
+          </a:xfrm>
+          <a:prstGeom prst="rect">
+            <a:avLst/>
+          </a:prstGeom>
+          <a:noFill/>
+          <a:ln/>
+        </p:spPr>
+        <p:txBody>
+          <a:bodyPr wrap="square" lIns="0" tIns="0" rIns="0" bIns="0" rtlCol="0" anchor="ctr"/>
+          <a:lstStyle/>
+          <a:p>
+            <a:pPr indent="0" marL="0">
+              <a:buNone/>
+            </a:pPr>
+            <a:r>
+              <a:rPr lang="en-US" sz="1400" b="1" spc="100" kern="0" dirty="0">
+                <a:solidFill>
+                  <a:srgbClr val="1C1C1C"/>
+                </a:solidFill>
+                <a:latin typeface="Geist" pitchFamily="34" charset="0"/>
+                <a:ea typeface="Geist" pitchFamily="34" charset="-122"/>
+                <a:cs typeface="Geist" pitchFamily="34" charset="-120"/>
+              </a:rPr>
+              <a:t>learn  with  </a:t>
+            </a:r>
+            <a:pPr indent="0" marL="0">
+              <a:buNone/>
+            </a:pPr>
+            <a:r>
+              <a:rPr lang="en-US" sz="1400" b="1" spc="100" kern="0" dirty="0">
+                <a:solidFill>
+                  <a:srgbClr val="FF5700"/>
+                </a:solidFill>
+                <a:latin typeface="Geist" pitchFamily="34" charset="0"/>
+                <a:ea typeface="Geist" pitchFamily="34" charset="-122"/>
+                <a:cs typeface="Geist" pitchFamily="34" charset="-120"/>
+              </a:rPr>
+              <a:t>harsha</a:t>
+            </a:r>
+            <a:pPr indent="0" marL="0">
+              <a:buNone/>
+            </a:pPr>
+            <a:r>
+              <a:rPr lang="en-US" sz="600" b="1" spc="100" kern="0" dirty="0">
+                <a:solidFill>
+                  <a:srgbClr val="FF5700"/>
+                </a:solidFill>
+                <a:latin typeface="Geist" pitchFamily="34" charset="0"/>
+                <a:ea typeface="Geist" pitchFamily="34" charset="-122"/>
+                <a:cs typeface="Geist" pitchFamily="34" charset="-120"/>
+              </a:rPr>
+              <a:t>  ■</a:t>
+            </a:r>
+            <a:endParaRPr lang="en-US" sz="1400" dirty="0"/>
+          </a:p>
+        </p:txBody>
+      </p:sp>
+      <p:sp>
+        <p:nvSpPr>
+          <p:cNvPr id="4" name="Shape 1"/>
+          <p:cNvSpPr/>
+          <p:nvPr/>
+        </p:nvSpPr>
+        <p:spPr>
+          <a:xfrm>
+            <a:off x="457200" y="905256"/>
+            <a:ext cx="91440" cy="91440"/>
+          </a:xfrm>
+          <a:prstGeom prst="rect">
+            <a:avLst/>
+          </a:prstGeom>
+          <a:solidFill>
+            <a:srgbClr val="FF5700"/>
+          </a:solidFill>
+          <a:ln/>
+        </p:spPr>
+      </p:sp>
+      <p:sp>
+        <p:nvSpPr>
+          <p:cNvPr id="5" name="Text 2"/>
+          <p:cNvSpPr txBox="1"/>
+          <p:nvPr/>
+        </p:nvSpPr>
+        <p:spPr>
+          <a:xfrm>
+            <a:off x="621792" y="804672"/>
+            <a:ext cx="6400800" cy="292608"/>
+          </a:xfrm>
+          <a:prstGeom prst="rect">
+            <a:avLst/>
+          </a:prstGeom>
+          <a:noFill/>
+          <a:ln/>
+        </p:spPr>
+        <p:txBody>
+          <a:bodyPr wrap="square" lIns="0" tIns="0" rIns="0" bIns="0" rtlCol="0" anchor="ctr"/>
+          <a:lstStyle/>
+          <a:p>
+            <a:pPr indent="0" marL="0">
+              <a:buNone/>
+            </a:pPr>
+            <a:r>
+              <a:rPr lang="en-US" sz="1000" spc="400" kern="0" dirty="0">
+                <a:solidFill>
+                  <a:srgbClr val="FF5700"/>
+                </a:solidFill>
+                <a:latin typeface="IBM Plex Mono" pitchFamily="34" charset="0"/>
+                <a:ea typeface="IBM Plex Mono" pitchFamily="34" charset="-122"/>
+                <a:cs typeface="IBM Plex Mono" pitchFamily="34" charset="-120"/>
+              </a:rPr>
+              <a:t>KEEPING IT SAFE</a:t>
+            </a:r>
+            <a:endParaRPr lang="en-US" sz="1000" dirty="0"/>
+          </a:p>
+        </p:txBody>
+      </p:sp>
+      <p:sp>
+        <p:nvSpPr>
+          <p:cNvPr id="6" name="Text 3"/>
+          <p:cNvSpPr txBox="1"/>
+          <p:nvPr/>
+        </p:nvSpPr>
+        <p:spPr>
+          <a:xfrm>
+            <a:off x="457200" y="1078992"/>
+            <a:ext cx="8229600" cy="640080"/>
+          </a:xfrm>
+          <a:prstGeom prst="rect">
+            <a:avLst/>
+          </a:prstGeom>
+          <a:noFill/>
+          <a:ln/>
+        </p:spPr>
+        <p:txBody>
+          <a:bodyPr wrap="square" lIns="0" tIns="0" rIns="0" bIns="0" rtlCol="0" anchor="ctr"/>
+          <a:lstStyle/>
+          <a:p>
+            <a:pPr indent="0" marL="0">
+              <a:buNone/>
+            </a:pPr>
+            <a:r>
+              <a:rPr lang="en-US" sz="2800" b="1" spc="-100" kern="0" dirty="0">
+                <a:solidFill>
+                  <a:srgbClr val="1C1C1C"/>
+                </a:solidFill>
+                <a:latin typeface="Geist" pitchFamily="34" charset="0"/>
+                <a:ea typeface="Geist" pitchFamily="34" charset="-122"/>
+                <a:cs typeface="Geist" pitchFamily="34" charset="-120"/>
+              </a:rPr>
+              <a:t>Policies vs guardrails</a:t>
+            </a:r>
+            <a:endParaRPr lang="en-US" sz="2800" dirty="0"/>
+          </a:p>
+        </p:txBody>
+      </p:sp>
+      <p:sp>
+        <p:nvSpPr>
+          <p:cNvPr id="7" name="Text 4"/>
+          <p:cNvSpPr txBox="1"/>
+          <p:nvPr/>
+        </p:nvSpPr>
+        <p:spPr>
+          <a:xfrm>
+            <a:off x="457200" y="4754880"/>
+            <a:ext cx="5943600" cy="228600"/>
+          </a:xfrm>
+          <a:prstGeom prst="rect">
+            <a:avLst/>
+          </a:prstGeom>
+          <a:noFill/>
+          <a:ln/>
+        </p:spPr>
+        <p:txBody>
+          <a:bodyPr wrap="square" lIns="0" tIns="0" rIns="0" bIns="0" rtlCol="0" anchor="ctr"/>
+          <a:lstStyle/>
+          <a:p>
+            <a:pPr indent="0" marL="0">
+              <a:buNone/>
+            </a:pPr>
+            <a:r>
+              <a:rPr lang="en-US" sz="800" spc="100" kern="0" dirty="0">
+                <a:solidFill>
+                  <a:srgbClr val="919191"/>
+                </a:solidFill>
+                <a:latin typeface="IBM Plex Mono" pitchFamily="34" charset="0"/>
+                <a:ea typeface="IBM Plex Mono" pitchFamily="34" charset="-122"/>
+                <a:cs typeface="IBM Plex Mono" pitchFamily="34" charset="-120"/>
+              </a:rPr>
+              <a:t>Arthashastra Learning · The Agentic Enterprise</a:t>
+            </a:r>
+            <a:endParaRPr lang="en-US" sz="800" dirty="0"/>
+          </a:p>
+        </p:txBody>
+      </p:sp>
+      <p:sp>
+        <p:nvSpPr>
+          <p:cNvPr id="8" name="Text 5"/>
+          <p:cNvSpPr txBox="1"/>
+          <p:nvPr/>
+        </p:nvSpPr>
+        <p:spPr>
+          <a:xfrm>
+            <a:off x="6858000" y="4754880"/>
+            <a:ext cx="1828800" cy="228600"/>
+          </a:xfrm>
+          <a:prstGeom prst="rect">
+            <a:avLst/>
+          </a:prstGeom>
+          <a:noFill/>
+          <a:ln/>
+        </p:spPr>
+        <p:txBody>
+          <a:bodyPr wrap="square" lIns="0" tIns="0" rIns="0" bIns="0" rtlCol="0" anchor="ctr"/>
+          <a:lstStyle/>
+          <a:p>
+            <a:pPr algn="r" indent="0" marL="0">
+              <a:buNone/>
+            </a:pPr>
+            <a:r>
+              <a:rPr lang="en-US" sz="800" spc="100" kern="0" dirty="0">
+                <a:solidFill>
+                  <a:srgbClr val="919191"/>
+                </a:solidFill>
+                <a:latin typeface="IBM Plex Mono" pitchFamily="34" charset="0"/>
+                <a:ea typeface="IBM Plex Mono" pitchFamily="34" charset="-122"/>
+                <a:cs typeface="IBM Plex Mono" pitchFamily="34" charset="-120"/>
+              </a:rPr>
+              <a:t>arthashastra.ai</a:t>
+            </a:r>
+            <a:endParaRPr lang="en-US" sz="800" dirty="0"/>
+          </a:p>
+        </p:txBody>
+      </p:sp>
+      <p:sp>
+        <p:nvSpPr>
+          <p:cNvPr id="9" name="Shape 6"/>
+          <p:cNvSpPr/>
+          <p:nvPr/>
+        </p:nvSpPr>
+        <p:spPr>
+          <a:xfrm>
+            <a:off x="457200" y="1783080"/>
+            <a:ext cx="3017520" cy="2331720"/>
+          </a:xfrm>
+          <a:prstGeom prst="rect">
+            <a:avLst/>
+          </a:prstGeom>
+          <a:solidFill>
+            <a:srgbClr val="F7F7F5"/>
+          </a:solidFill>
+          <a:ln w="9525">
+            <a:solidFill>
+              <a:srgbClr val="E5E5E5"/>
+            </a:solidFill>
+            <a:prstDash val="solid"/>
+          </a:ln>
+        </p:spPr>
+      </p:sp>
+      <p:sp>
+        <p:nvSpPr>
+          <p:cNvPr id="10" name="Text 7"/>
+          <p:cNvSpPr txBox="1"/>
+          <p:nvPr/>
+        </p:nvSpPr>
+        <p:spPr>
+          <a:xfrm>
+            <a:off x="640080" y="1901952"/>
+            <a:ext cx="2651760" cy="320040"/>
+          </a:xfrm>
+          <a:prstGeom prst="rect">
+            <a:avLst/>
+          </a:prstGeom>
+          <a:noFill/>
+          <a:ln/>
+        </p:spPr>
+        <p:txBody>
+          <a:bodyPr wrap="square" lIns="0" tIns="0" rIns="0" bIns="0" rtlCol="0" anchor="t"/>
+          <a:lstStyle/>
+          <a:p>
+            <a:pPr indent="0" marL="0">
+              <a:buNone/>
+            </a:pPr>
+            <a:r>
+              <a:rPr lang="en-US" sz="1500" b="1" spc="-50" kern="0" dirty="0">
+                <a:solidFill>
+                  <a:srgbClr val="1C1C1C"/>
+                </a:solidFill>
+                <a:latin typeface="Geist" pitchFamily="34" charset="0"/>
+                <a:ea typeface="Geist" pitchFamily="34" charset="-122"/>
+                <a:cs typeface="Geist" pitchFamily="34" charset="-120"/>
+              </a:rPr>
+              <a:t>Policies</a:t>
+            </a:r>
+            <a:endParaRPr lang="en-US" sz="1500" dirty="0"/>
+          </a:p>
+        </p:txBody>
+      </p:sp>
+      <p:sp>
+        <p:nvSpPr>
+          <p:cNvPr id="11" name="Text 8"/>
+          <p:cNvSpPr txBox="1"/>
+          <p:nvPr/>
+        </p:nvSpPr>
+        <p:spPr>
+          <a:xfrm>
+            <a:off x="640080" y="2212848"/>
+            <a:ext cx="2651760" cy="228600"/>
+          </a:xfrm>
+          <a:prstGeom prst="rect">
+            <a:avLst/>
+          </a:prstGeom>
+          <a:noFill/>
+          <a:ln/>
+        </p:spPr>
+        <p:txBody>
+          <a:bodyPr wrap="square" lIns="0" tIns="0" rIns="0" bIns="0" rtlCol="0" anchor="t"/>
+          <a:lstStyle/>
+          <a:p>
+            <a:pPr indent="0" marL="0">
+              <a:buNone/>
+            </a:pPr>
+            <a:r>
+              <a:rPr lang="en-US" sz="750" dirty="0">
+                <a:solidFill>
+                  <a:srgbClr val="FF5700"/>
+                </a:solidFill>
+                <a:latin typeface="IBM Plex Mono" pitchFamily="34" charset="0"/>
+                <a:ea typeface="IBM Plex Mono" pitchFamily="34" charset="-122"/>
+                <a:cs typeface="IBM Plex Mono" pitchFamily="34" charset="-120"/>
+              </a:rPr>
+              <a:t>WRITTEN BY THE BUSINESS</a:t>
+            </a:r>
+            <a:endParaRPr lang="en-US" sz="750" dirty="0"/>
+          </a:p>
+        </p:txBody>
+      </p:sp>
+      <p:sp>
+        <p:nvSpPr>
+          <p:cNvPr id="12" name="Text 9"/>
+          <p:cNvSpPr txBox="1"/>
+          <p:nvPr/>
+        </p:nvSpPr>
+        <p:spPr>
+          <a:xfrm>
+            <a:off x="640080" y="2487168"/>
+            <a:ext cx="2697480" cy="1280160"/>
+          </a:xfrm>
+          <a:prstGeom prst="rect">
+            <a:avLst/>
+          </a:prstGeom>
+          <a:noFill/>
+          <a:ln/>
+        </p:spPr>
+        <p:txBody>
+          <a:bodyPr wrap="square" lIns="0" tIns="0" rIns="0" bIns="0" rtlCol="0" anchor="t"/>
+          <a:lstStyle/>
+          <a:p>
+            <a:pPr indent="0" marL="0">
+              <a:buNone/>
+            </a:pPr>
+            <a:r>
+              <a:rPr lang="en-US" sz="950" dirty="0">
+                <a:solidFill>
+                  <a:srgbClr val="1C1C1C"/>
+                </a:solidFill>
+                <a:latin typeface="Geist" pitchFamily="34" charset="0"/>
+                <a:ea typeface="Geist" pitchFamily="34" charset="-122"/>
+                <a:cs typeface="Geist" pitchFamily="34" charset="-120"/>
+              </a:rPr>
+              <a:t>Scope — what it exists to do, what it never touches</a:t>
+            </a:r>
+            <a:endParaRPr lang="en-US" sz="950" dirty="0"/>
+          </a:p>
+          <a:p>
+            <a:pPr indent="0" marL="0">
+              <a:buNone/>
+            </a:pPr>
+            <a:r>
+              <a:rPr lang="en-US" sz="950" dirty="0">
+                <a:solidFill>
+                  <a:srgbClr val="1C1C1C"/>
+                </a:solidFill>
+                <a:latin typeface="Geist" pitchFamily="34" charset="0"/>
+                <a:ea typeface="Geist" pitchFamily="34" charset="-122"/>
+                <a:cs typeface="Geist" pitchFamily="34" charset="-120"/>
+              </a:rPr>
+              <a:t>Thresholds — auto-approve under 25,000; above needs a named approver</a:t>
+            </a:r>
+            <a:endParaRPr lang="en-US" sz="950" dirty="0"/>
+          </a:p>
+          <a:p>
+            <a:pPr indent="0" marL="0">
+              <a:buNone/>
+            </a:pPr>
+            <a:r>
+              <a:rPr lang="en-US" sz="950" dirty="0">
+                <a:solidFill>
+                  <a:srgbClr val="1C1C1C"/>
+                </a:solidFill>
+                <a:latin typeface="Geist" pitchFamily="34" charset="0"/>
+                <a:ea typeface="Geist" pitchFamily="34" charset="-122"/>
+                <a:cs typeface="Geist" pitchFamily="34" charset="-120"/>
+              </a:rPr>
+              <a:t>Data boundaries — one company; no PII in prompts or logs</a:t>
+            </a:r>
+            <a:endParaRPr lang="en-US" sz="950" dirty="0"/>
+          </a:p>
+          <a:p>
+            <a:pPr indent="0" marL="0">
+              <a:buNone/>
+            </a:pPr>
+            <a:r>
+              <a:rPr lang="en-US" sz="950" dirty="0">
+                <a:solidFill>
+                  <a:srgbClr val="1C1C1C"/>
+                </a:solidFill>
+                <a:latin typeface="Geist" pitchFamily="34" charset="0"/>
+                <a:ea typeface="Geist" pitchFamily="34" charset="-122"/>
+                <a:cs typeface="Geist" pitchFamily="34" charset="-120"/>
+              </a:rPr>
+              <a:t>Behaviour — check policy before booking; escalate when unsure</a:t>
+            </a:r>
+            <a:endParaRPr lang="en-US" sz="950" dirty="0"/>
+          </a:p>
+        </p:txBody>
+      </p:sp>
+      <p:sp>
+        <p:nvSpPr>
+          <p:cNvPr id="13" name="Text 10"/>
+          <p:cNvSpPr txBox="1"/>
+          <p:nvPr/>
+        </p:nvSpPr>
+        <p:spPr>
+          <a:xfrm>
+            <a:off x="640080" y="3767328"/>
+            <a:ext cx="2697480" cy="320040"/>
+          </a:xfrm>
+          <a:prstGeom prst="rect">
+            <a:avLst/>
+          </a:prstGeom>
+          <a:noFill/>
+          <a:ln/>
+        </p:spPr>
+        <p:txBody>
+          <a:bodyPr wrap="square" lIns="0" tIns="0" rIns="0" bIns="0" rtlCol="0" anchor="t"/>
+          <a:lstStyle/>
+          <a:p>
+            <a:pPr indent="0" marL="0">
+              <a:buNone/>
+            </a:pPr>
+            <a:r>
+              <a:rPr lang="en-US" sz="850" dirty="0">
+                <a:solidFill>
+                  <a:srgbClr val="6B7280"/>
+                </a:solidFill>
+                <a:latin typeface="Geist" pitchFamily="34" charset="0"/>
+                <a:ea typeface="Geist" pitchFamily="34" charset="-122"/>
+                <a:cs typeface="Geist" pitchFamily="34" charset="-120"/>
+              </a:rPr>
+              <a:t>Goes in the system prompt — a request, not a guarantee.</a:t>
+            </a:r>
+            <a:endParaRPr lang="en-US" sz="850" dirty="0"/>
+          </a:p>
+        </p:txBody>
+      </p:sp>
+      <p:sp>
+        <p:nvSpPr>
+          <p:cNvPr id="14" name="Text 11"/>
+          <p:cNvSpPr txBox="1"/>
+          <p:nvPr/>
+        </p:nvSpPr>
+        <p:spPr>
+          <a:xfrm>
+            <a:off x="3749040" y="1810512"/>
+            <a:ext cx="2743200" cy="274320"/>
+          </a:xfrm>
+          <a:prstGeom prst="rect">
+            <a:avLst/>
+          </a:prstGeom>
+          <a:noFill/>
+          <a:ln/>
+        </p:spPr>
+        <p:txBody>
+          <a:bodyPr wrap="square" lIns="0" tIns="0" rIns="0" bIns="0" rtlCol="0" anchor="t"/>
+          <a:lstStyle/>
+          <a:p>
+            <a:pPr indent="0" marL="0">
+              <a:buNone/>
+            </a:pPr>
+            <a:r>
+              <a:rPr lang="en-US" sz="1500" b="1" spc="-50" kern="0" dirty="0">
+                <a:solidFill>
+                  <a:srgbClr val="1C1C1C"/>
+                </a:solidFill>
+                <a:latin typeface="Geist" pitchFamily="34" charset="0"/>
+                <a:ea typeface="Geist" pitchFamily="34" charset="-122"/>
+                <a:cs typeface="Geist" pitchFamily="34" charset="-120"/>
+              </a:rPr>
+              <a:t>Guardrails</a:t>
+            </a:r>
+            <a:endParaRPr lang="en-US" sz="1500" dirty="0"/>
+          </a:p>
+        </p:txBody>
+      </p:sp>
+      <p:sp>
+        <p:nvSpPr>
+          <p:cNvPr id="15" name="Text 12"/>
+          <p:cNvSpPr txBox="1"/>
+          <p:nvPr/>
+        </p:nvSpPr>
+        <p:spPr>
+          <a:xfrm>
+            <a:off x="6309360" y="1874520"/>
+            <a:ext cx="2377440" cy="228600"/>
+          </a:xfrm>
+          <a:prstGeom prst="rect">
+            <a:avLst/>
+          </a:prstGeom>
+          <a:noFill/>
+          <a:ln/>
+        </p:spPr>
+        <p:txBody>
+          <a:bodyPr wrap="square" lIns="0" tIns="0" rIns="0" bIns="0" rtlCol="0" anchor="t"/>
+          <a:lstStyle/>
+          <a:p>
+            <a:pPr indent="0" marL="0">
+              <a:buNone/>
+            </a:pPr>
+            <a:r>
+              <a:rPr lang="en-US" sz="750" dirty="0">
+                <a:solidFill>
+                  <a:srgbClr val="FF5700"/>
+                </a:solidFill>
+                <a:latin typeface="IBM Plex Mono" pitchFamily="34" charset="0"/>
+                <a:ea typeface="IBM Plex Mono" pitchFamily="34" charset="-122"/>
+                <a:cs typeface="IBM Plex Mono" pitchFamily="34" charset="-120"/>
+              </a:rPr>
+              <a:t>ENFORCED IN CODE</a:t>
+            </a:r>
+            <a:endParaRPr lang="en-US" sz="750" dirty="0"/>
+          </a:p>
+        </p:txBody>
+      </p:sp>
+      <p:sp>
+        <p:nvSpPr>
+          <p:cNvPr id="16" name="Shape 13"/>
+          <p:cNvSpPr/>
+          <p:nvPr/>
+        </p:nvSpPr>
+        <p:spPr>
+          <a:xfrm>
+            <a:off x="3749040" y="2185416"/>
+            <a:ext cx="256032" cy="256032"/>
+          </a:xfrm>
+          <a:prstGeom prst="rect">
+            <a:avLst/>
+          </a:prstGeom>
+          <a:solidFill>
+            <a:srgbClr val="FF5700"/>
+          </a:solidFill>
+          <a:ln/>
+        </p:spPr>
+      </p:sp>
+      <p:sp>
+        <p:nvSpPr>
+          <p:cNvPr id="17" name="Text 14"/>
+          <p:cNvSpPr txBox="1"/>
+          <p:nvPr/>
+        </p:nvSpPr>
+        <p:spPr>
+          <a:xfrm>
+            <a:off x="3749040" y="2185416"/>
+            <a:ext cx="256032" cy="256032"/>
+          </a:xfrm>
+          <a:prstGeom prst="rect">
+            <a:avLst/>
+          </a:prstGeom>
+          <a:noFill/>
+          <a:ln/>
+        </p:spPr>
+        <p:txBody>
+          <a:bodyPr wrap="square" lIns="0" tIns="0" rIns="0" bIns="0" rtlCol="0" anchor="ctr"/>
+          <a:lstStyle/>
+          <a:p>
+            <a:pPr algn="ctr" indent="0" marL="0">
+              <a:buNone/>
+            </a:pPr>
+            <a:r>
+              <a:rPr lang="en-US" sz="1100" b="1" dirty="0">
+                <a:solidFill>
+                  <a:srgbClr val="FFFFFF"/>
+                </a:solidFill>
+                <a:latin typeface="IBM Plex Mono" pitchFamily="34" charset="0"/>
+                <a:ea typeface="IBM Plex Mono" pitchFamily="34" charset="-122"/>
+                <a:cs typeface="IBM Plex Mono" pitchFamily="34" charset="-120"/>
+              </a:rPr>
+              <a:t>1</a:t>
+            </a:r>
+            <a:endParaRPr lang="en-US" sz="1100" dirty="0"/>
+          </a:p>
+        </p:txBody>
+      </p:sp>
+      <p:sp>
+        <p:nvSpPr>
+          <p:cNvPr id="18" name="Text 15"/>
+          <p:cNvSpPr txBox="1"/>
+          <p:nvPr/>
+        </p:nvSpPr>
+        <p:spPr>
+          <a:xfrm>
+            <a:off x="4114800" y="2148840"/>
+            <a:ext cx="1645920" cy="320040"/>
+          </a:xfrm>
+          <a:prstGeom prst="rect">
+            <a:avLst/>
+          </a:prstGeom>
+          <a:noFill/>
+          <a:ln/>
+        </p:spPr>
+        <p:txBody>
+          <a:bodyPr wrap="square" lIns="0" tIns="0" rIns="0" bIns="0" rtlCol="0" anchor="t"/>
+          <a:lstStyle/>
+          <a:p>
+            <a:pPr indent="0" marL="0">
+              <a:buNone/>
+            </a:pPr>
+            <a:r>
+              <a:rPr lang="en-US" sz="1100" b="1" spc="-50" kern="0" dirty="0">
+                <a:solidFill>
+                  <a:srgbClr val="1C1C1C"/>
+                </a:solidFill>
+                <a:latin typeface="Geist" pitchFamily="34" charset="0"/>
+                <a:ea typeface="Geist" pitchFamily="34" charset="-122"/>
+                <a:cs typeface="Geist" pitchFamily="34" charset="-120"/>
+              </a:rPr>
+              <a:t>Input</a:t>
+            </a:r>
+            <a:endParaRPr lang="en-US" sz="1100" dirty="0"/>
+          </a:p>
+        </p:txBody>
+      </p:sp>
+      <p:sp>
+        <p:nvSpPr>
+          <p:cNvPr id="19" name="Text 16"/>
+          <p:cNvSpPr txBox="1"/>
+          <p:nvPr/>
+        </p:nvSpPr>
+        <p:spPr>
+          <a:xfrm>
+            <a:off x="5760720" y="2167128"/>
+            <a:ext cx="2926080" cy="384048"/>
+          </a:xfrm>
+          <a:prstGeom prst="rect">
+            <a:avLst/>
+          </a:prstGeom>
+          <a:noFill/>
+          <a:ln/>
+        </p:spPr>
+        <p:txBody>
+          <a:bodyPr wrap="square" lIns="0" tIns="0" rIns="0" bIns="0" rtlCol="0" anchor="t"/>
+          <a:lstStyle/>
+          <a:p>
+            <a:pPr indent="0" marL="0">
+              <a:buNone/>
+            </a:pPr>
+            <a:r>
+              <a:rPr lang="en-US" sz="850" dirty="0">
+                <a:solidFill>
+                  <a:srgbClr val="6B7280"/>
+                </a:solidFill>
+                <a:latin typeface="Geist" pitchFamily="34" charset="0"/>
+                <a:ea typeface="Geist" pitchFamily="34" charset="-122"/>
+                <a:cs typeface="Geist" pitchFamily="34" charset="-120"/>
+              </a:rPr>
+              <a:t>sanitise the request; catch injected instructions; check identity and company</a:t>
+            </a:r>
+            <a:endParaRPr lang="en-US" sz="850" dirty="0"/>
+          </a:p>
+        </p:txBody>
+      </p:sp>
+      <p:sp>
+        <p:nvSpPr>
+          <p:cNvPr id="20" name="Shape 17"/>
+          <p:cNvSpPr/>
+          <p:nvPr/>
+        </p:nvSpPr>
+        <p:spPr>
+          <a:xfrm>
+            <a:off x="3749040" y="2587752"/>
+            <a:ext cx="256032" cy="256032"/>
+          </a:xfrm>
+          <a:prstGeom prst="rect">
+            <a:avLst/>
+          </a:prstGeom>
+          <a:solidFill>
+            <a:srgbClr val="FF5700"/>
+          </a:solidFill>
+          <a:ln/>
+        </p:spPr>
+      </p:sp>
+      <p:sp>
+        <p:nvSpPr>
+          <p:cNvPr id="21" name="Text 18"/>
+          <p:cNvSpPr txBox="1"/>
+          <p:nvPr/>
+        </p:nvSpPr>
+        <p:spPr>
+          <a:xfrm>
+            <a:off x="3749040" y="2587752"/>
+            <a:ext cx="256032" cy="256032"/>
+          </a:xfrm>
+          <a:prstGeom prst="rect">
+            <a:avLst/>
+          </a:prstGeom>
+          <a:noFill/>
+          <a:ln/>
+        </p:spPr>
+        <p:txBody>
+          <a:bodyPr wrap="square" lIns="0" tIns="0" rIns="0" bIns="0" rtlCol="0" anchor="ctr"/>
+          <a:lstStyle/>
+          <a:p>
+            <a:pPr algn="ctr" indent="0" marL="0">
+              <a:buNone/>
+            </a:pPr>
+            <a:r>
+              <a:rPr lang="en-US" sz="1100" b="1" dirty="0">
+                <a:solidFill>
+                  <a:srgbClr val="FFFFFF"/>
+                </a:solidFill>
+                <a:latin typeface="IBM Plex Mono" pitchFamily="34" charset="0"/>
+                <a:ea typeface="IBM Plex Mono" pitchFamily="34" charset="-122"/>
+                <a:cs typeface="IBM Plex Mono" pitchFamily="34" charset="-120"/>
+              </a:rPr>
+              <a:t>2</a:t>
+            </a:r>
+            <a:endParaRPr lang="en-US" sz="1100" dirty="0"/>
+          </a:p>
+        </p:txBody>
+      </p:sp>
+      <p:sp>
+        <p:nvSpPr>
+          <p:cNvPr id="22" name="Text 19"/>
+          <p:cNvSpPr txBox="1"/>
+          <p:nvPr/>
+        </p:nvSpPr>
+        <p:spPr>
+          <a:xfrm>
+            <a:off x="4114800" y="2551176"/>
+            <a:ext cx="1645920" cy="320040"/>
+          </a:xfrm>
+          <a:prstGeom prst="rect">
+            <a:avLst/>
+          </a:prstGeom>
+          <a:noFill/>
+          <a:ln/>
+        </p:spPr>
+        <p:txBody>
+          <a:bodyPr wrap="square" lIns="0" tIns="0" rIns="0" bIns="0" rtlCol="0" anchor="t"/>
+          <a:lstStyle/>
+          <a:p>
+            <a:pPr indent="0" marL="0">
+              <a:buNone/>
+            </a:pPr>
+            <a:r>
+              <a:rPr lang="en-US" sz="1100" b="1" spc="-50" kern="0" dirty="0">
+                <a:solidFill>
+                  <a:srgbClr val="1C1C1C"/>
+                </a:solidFill>
+                <a:latin typeface="Geist" pitchFamily="34" charset="0"/>
+                <a:ea typeface="Geist" pitchFamily="34" charset="-122"/>
+                <a:cs typeface="Geist" pitchFamily="34" charset="-120"/>
+              </a:rPr>
+              <a:t>Tool</a:t>
+            </a:r>
+            <a:endParaRPr lang="en-US" sz="1100" dirty="0"/>
+          </a:p>
+        </p:txBody>
+      </p:sp>
+      <p:sp>
+        <p:nvSpPr>
+          <p:cNvPr id="23" name="Text 20"/>
+          <p:cNvSpPr txBox="1"/>
+          <p:nvPr/>
+        </p:nvSpPr>
+        <p:spPr>
+          <a:xfrm>
+            <a:off x="5760720" y="2569464"/>
+            <a:ext cx="2926080" cy="384048"/>
+          </a:xfrm>
+          <a:prstGeom prst="rect">
+            <a:avLst/>
+          </a:prstGeom>
+          <a:noFill/>
+          <a:ln/>
+        </p:spPr>
+        <p:txBody>
+          <a:bodyPr wrap="square" lIns="0" tIns="0" rIns="0" bIns="0" rtlCol="0" anchor="t"/>
+          <a:lstStyle/>
+          <a:p>
+            <a:pPr indent="0" marL="0">
+              <a:buNone/>
+            </a:pPr>
+            <a:r>
+              <a:rPr lang="en-US" sz="850" dirty="0">
+                <a:solidFill>
+                  <a:srgbClr val="6B7280"/>
+                </a:solidFill>
+                <a:latin typeface="Geist" pitchFamily="34" charset="0"/>
+                <a:ea typeface="Geist" pitchFamily="34" charset="-122"/>
+                <a:cs typeface="Geist" pitchFamily="34" charset="-120"/>
+              </a:rPr>
+              <a:t>least privilege; schema checks; caps; tenant filter server-side; read-only by default</a:t>
+            </a:r>
+            <a:endParaRPr lang="en-US" sz="850" dirty="0"/>
+          </a:p>
+        </p:txBody>
+      </p:sp>
+      <p:sp>
+        <p:nvSpPr>
+          <p:cNvPr id="24" name="Shape 21"/>
+          <p:cNvSpPr/>
+          <p:nvPr/>
+        </p:nvSpPr>
+        <p:spPr>
+          <a:xfrm>
+            <a:off x="3749040" y="2990088"/>
+            <a:ext cx="256032" cy="256032"/>
+          </a:xfrm>
+          <a:prstGeom prst="rect">
+            <a:avLst/>
+          </a:prstGeom>
+          <a:solidFill>
+            <a:srgbClr val="FF5700"/>
+          </a:solidFill>
+          <a:ln/>
+        </p:spPr>
+      </p:sp>
+      <p:sp>
+        <p:nvSpPr>
+          <p:cNvPr id="25" name="Text 22"/>
+          <p:cNvSpPr txBox="1"/>
+          <p:nvPr/>
+        </p:nvSpPr>
+        <p:spPr>
+          <a:xfrm>
+            <a:off x="3749040" y="2990088"/>
+            <a:ext cx="256032" cy="256032"/>
+          </a:xfrm>
+          <a:prstGeom prst="rect">
+            <a:avLst/>
+          </a:prstGeom>
+          <a:noFill/>
+          <a:ln/>
+        </p:spPr>
+        <p:txBody>
+          <a:bodyPr wrap="square" lIns="0" tIns="0" rIns="0" bIns="0" rtlCol="0" anchor="ctr"/>
+          <a:lstStyle/>
+          <a:p>
+            <a:pPr algn="ctr" indent="0" marL="0">
+              <a:buNone/>
+            </a:pPr>
+            <a:r>
+              <a:rPr lang="en-US" sz="1100" b="1" dirty="0">
+                <a:solidFill>
+                  <a:srgbClr val="FFFFFF"/>
+                </a:solidFill>
+                <a:latin typeface="IBM Plex Mono" pitchFamily="34" charset="0"/>
+                <a:ea typeface="IBM Plex Mono" pitchFamily="34" charset="-122"/>
+                <a:cs typeface="IBM Plex Mono" pitchFamily="34" charset="-120"/>
+              </a:rPr>
+              <a:t>3</a:t>
+            </a:r>
+            <a:endParaRPr lang="en-US" sz="1100" dirty="0"/>
+          </a:p>
+        </p:txBody>
+      </p:sp>
+      <p:sp>
+        <p:nvSpPr>
+          <p:cNvPr id="26" name="Text 23"/>
+          <p:cNvSpPr txBox="1"/>
+          <p:nvPr/>
+        </p:nvSpPr>
+        <p:spPr>
+          <a:xfrm>
+            <a:off x="4114800" y="2953512"/>
+            <a:ext cx="1645920" cy="320040"/>
+          </a:xfrm>
+          <a:prstGeom prst="rect">
+            <a:avLst/>
+          </a:prstGeom>
+          <a:noFill/>
+          <a:ln/>
+        </p:spPr>
+        <p:txBody>
+          <a:bodyPr wrap="square" lIns="0" tIns="0" rIns="0" bIns="0" rtlCol="0" anchor="t"/>
+          <a:lstStyle/>
+          <a:p>
+            <a:pPr indent="0" marL="0">
+              <a:buNone/>
+            </a:pPr>
+            <a:r>
+              <a:rPr lang="en-US" sz="1100" b="1" spc="-50" kern="0" dirty="0">
+                <a:solidFill>
+                  <a:srgbClr val="1C1C1C"/>
+                </a:solidFill>
+                <a:latin typeface="Geist" pitchFamily="34" charset="0"/>
+                <a:ea typeface="Geist" pitchFamily="34" charset="-122"/>
+                <a:cs typeface="Geist" pitchFamily="34" charset="-120"/>
+              </a:rPr>
+              <a:t>Output</a:t>
+            </a:r>
+            <a:endParaRPr lang="en-US" sz="1100" dirty="0"/>
+          </a:p>
+        </p:txBody>
+      </p:sp>
+      <p:sp>
+        <p:nvSpPr>
+          <p:cNvPr id="27" name="Text 24"/>
+          <p:cNvSpPr txBox="1"/>
+          <p:nvPr/>
+        </p:nvSpPr>
+        <p:spPr>
+          <a:xfrm>
+            <a:off x="5760720" y="2971800"/>
+            <a:ext cx="2926080" cy="384048"/>
+          </a:xfrm>
+          <a:prstGeom prst="rect">
+            <a:avLst/>
+          </a:prstGeom>
+          <a:noFill/>
+          <a:ln/>
+        </p:spPr>
+        <p:txBody>
+          <a:bodyPr wrap="square" lIns="0" tIns="0" rIns="0" bIns="0" rtlCol="0" anchor="t"/>
+          <a:lstStyle/>
+          <a:p>
+            <a:pPr indent="0" marL="0">
+              <a:buNone/>
+            </a:pPr>
+            <a:r>
+              <a:rPr lang="en-US" sz="850" dirty="0">
+                <a:solidFill>
+                  <a:srgbClr val="6B7280"/>
+                </a:solidFill>
+                <a:latin typeface="Geist" pitchFamily="34" charset="0"/>
+                <a:ea typeface="Geist" pitchFamily="34" charset="-122"/>
+                <a:cs typeface="Geist" pitchFamily="34" charset="-120"/>
+              </a:rPr>
+              <a:t>no leaked data; no invented document numbers; no claimed actions that didn't happen</a:t>
+            </a:r>
+            <a:endParaRPr lang="en-US" sz="850" dirty="0"/>
+          </a:p>
+        </p:txBody>
+      </p:sp>
+      <p:sp>
+        <p:nvSpPr>
+          <p:cNvPr id="28" name="Shape 25"/>
+          <p:cNvSpPr/>
+          <p:nvPr/>
+        </p:nvSpPr>
+        <p:spPr>
+          <a:xfrm>
+            <a:off x="3749040" y="3392424"/>
+            <a:ext cx="256032" cy="256032"/>
+          </a:xfrm>
+          <a:prstGeom prst="rect">
+            <a:avLst/>
+          </a:prstGeom>
+          <a:solidFill>
+            <a:srgbClr val="FF5700"/>
+          </a:solidFill>
+          <a:ln/>
+        </p:spPr>
+      </p:sp>
+      <p:sp>
+        <p:nvSpPr>
+          <p:cNvPr id="29" name="Text 26"/>
+          <p:cNvSpPr txBox="1"/>
+          <p:nvPr/>
+        </p:nvSpPr>
+        <p:spPr>
+          <a:xfrm>
+            <a:off x="3749040" y="3392424"/>
+            <a:ext cx="256032" cy="256032"/>
+          </a:xfrm>
+          <a:prstGeom prst="rect">
+            <a:avLst/>
+          </a:prstGeom>
+          <a:noFill/>
+          <a:ln/>
+        </p:spPr>
+        <p:txBody>
+          <a:bodyPr wrap="square" lIns="0" tIns="0" rIns="0" bIns="0" rtlCol="0" anchor="ctr"/>
+          <a:lstStyle/>
+          <a:p>
+            <a:pPr algn="ctr" indent="0" marL="0">
+              <a:buNone/>
+            </a:pPr>
+            <a:r>
+              <a:rPr lang="en-US" sz="1100" b="1" dirty="0">
+                <a:solidFill>
+                  <a:srgbClr val="FFFFFF"/>
+                </a:solidFill>
+                <a:latin typeface="IBM Plex Mono" pitchFamily="34" charset="0"/>
+                <a:ea typeface="IBM Plex Mono" pitchFamily="34" charset="-122"/>
+                <a:cs typeface="IBM Plex Mono" pitchFamily="34" charset="-120"/>
+              </a:rPr>
+              <a:t>4</a:t>
+            </a:r>
+            <a:endParaRPr lang="en-US" sz="1100" dirty="0"/>
+          </a:p>
+        </p:txBody>
+      </p:sp>
+      <p:sp>
+        <p:nvSpPr>
+          <p:cNvPr id="30" name="Text 27"/>
+          <p:cNvSpPr txBox="1"/>
+          <p:nvPr/>
+        </p:nvSpPr>
+        <p:spPr>
+          <a:xfrm>
+            <a:off x="4114800" y="3355848"/>
+            <a:ext cx="1645920" cy="320040"/>
+          </a:xfrm>
+          <a:prstGeom prst="rect">
+            <a:avLst/>
+          </a:prstGeom>
+          <a:noFill/>
+          <a:ln/>
+        </p:spPr>
+        <p:txBody>
+          <a:bodyPr wrap="square" lIns="0" tIns="0" rIns="0" bIns="0" rtlCol="0" anchor="t"/>
+          <a:lstStyle/>
+          <a:p>
+            <a:pPr indent="0" marL="0">
+              <a:buNone/>
+            </a:pPr>
+            <a:r>
+              <a:rPr lang="en-US" sz="1100" b="1" spc="-50" kern="0" dirty="0">
+                <a:solidFill>
+                  <a:srgbClr val="1C1C1C"/>
+                </a:solidFill>
+                <a:latin typeface="Geist" pitchFamily="34" charset="0"/>
+                <a:ea typeface="Geist" pitchFamily="34" charset="-122"/>
+                <a:cs typeface="Geist" pitchFamily="34" charset="-120"/>
+              </a:rPr>
+              <a:t>Runtime</a:t>
+            </a:r>
+            <a:endParaRPr lang="en-US" sz="1100" dirty="0"/>
+          </a:p>
+        </p:txBody>
+      </p:sp>
+      <p:sp>
+        <p:nvSpPr>
+          <p:cNvPr id="31" name="Text 28"/>
+          <p:cNvSpPr txBox="1"/>
+          <p:nvPr/>
+        </p:nvSpPr>
+        <p:spPr>
+          <a:xfrm>
+            <a:off x="5760720" y="3374136"/>
+            <a:ext cx="2926080" cy="384048"/>
+          </a:xfrm>
+          <a:prstGeom prst="rect">
+            <a:avLst/>
+          </a:prstGeom>
+          <a:noFill/>
+          <a:ln/>
+        </p:spPr>
+        <p:txBody>
+          <a:bodyPr wrap="square" lIns="0" tIns="0" rIns="0" bIns="0" rtlCol="0" anchor="t"/>
+          <a:lstStyle/>
+          <a:p>
+            <a:pPr indent="0" marL="0">
+              <a:buNone/>
+            </a:pPr>
+            <a:r>
+              <a:rPr lang="en-US" sz="850" dirty="0">
+                <a:solidFill>
+                  <a:srgbClr val="6B7280"/>
+                </a:solidFill>
+                <a:latin typeface="Geist" pitchFamily="34" charset="0"/>
+                <a:ea typeface="Geist" pitchFamily="34" charset="-122"/>
+                <a:cs typeface="Geist" pitchFamily="34" charset="-120"/>
+              </a:rPr>
+              <a:t>step cap; cost budget; timeout; kill switch per agent</a:t>
+            </a:r>
+            <a:endParaRPr lang="en-US" sz="850" dirty="0"/>
+          </a:p>
+        </p:txBody>
+      </p:sp>
+      <p:sp>
+        <p:nvSpPr>
+          <p:cNvPr id="32" name="Shape 29"/>
+          <p:cNvSpPr/>
+          <p:nvPr/>
+        </p:nvSpPr>
+        <p:spPr>
+          <a:xfrm>
+            <a:off x="3749040" y="3794760"/>
+            <a:ext cx="256032" cy="256032"/>
+          </a:xfrm>
+          <a:prstGeom prst="rect">
+            <a:avLst/>
+          </a:prstGeom>
+          <a:solidFill>
+            <a:srgbClr val="FF5700"/>
+          </a:solidFill>
+          <a:ln/>
+        </p:spPr>
+      </p:sp>
+      <p:sp>
+        <p:nvSpPr>
+          <p:cNvPr id="33" name="Text 30"/>
+          <p:cNvSpPr txBox="1"/>
+          <p:nvPr/>
+        </p:nvSpPr>
+        <p:spPr>
+          <a:xfrm>
+            <a:off x="3749040" y="3794760"/>
+            <a:ext cx="256032" cy="256032"/>
+          </a:xfrm>
+          <a:prstGeom prst="rect">
+            <a:avLst/>
+          </a:prstGeom>
+          <a:noFill/>
+          <a:ln/>
+        </p:spPr>
+        <p:txBody>
+          <a:bodyPr wrap="square" lIns="0" tIns="0" rIns="0" bIns="0" rtlCol="0" anchor="ctr"/>
+          <a:lstStyle/>
+          <a:p>
+            <a:pPr algn="ctr" indent="0" marL="0">
+              <a:buNone/>
+            </a:pPr>
+            <a:r>
+              <a:rPr lang="en-US" sz="1100" b="1" dirty="0">
+                <a:solidFill>
+                  <a:srgbClr val="FFFFFF"/>
+                </a:solidFill>
+                <a:latin typeface="IBM Plex Mono" pitchFamily="34" charset="0"/>
+                <a:ea typeface="IBM Plex Mono" pitchFamily="34" charset="-122"/>
+                <a:cs typeface="IBM Plex Mono" pitchFamily="34" charset="-120"/>
+              </a:rPr>
+              <a:t>5</a:t>
+            </a:r>
+            <a:endParaRPr lang="en-US" sz="1100" dirty="0"/>
+          </a:p>
+        </p:txBody>
+      </p:sp>
+      <p:sp>
+        <p:nvSpPr>
+          <p:cNvPr id="34" name="Text 31"/>
+          <p:cNvSpPr txBox="1"/>
+          <p:nvPr/>
+        </p:nvSpPr>
+        <p:spPr>
+          <a:xfrm>
+            <a:off x="4114800" y="3758184"/>
+            <a:ext cx="1645920" cy="320040"/>
+          </a:xfrm>
+          <a:prstGeom prst="rect">
+            <a:avLst/>
+          </a:prstGeom>
+          <a:noFill/>
+          <a:ln/>
+        </p:spPr>
+        <p:txBody>
+          <a:bodyPr wrap="square" lIns="0" tIns="0" rIns="0" bIns="0" rtlCol="0" anchor="t"/>
+          <a:lstStyle/>
+          <a:p>
+            <a:pPr indent="0" marL="0">
+              <a:buNone/>
+            </a:pPr>
+            <a:r>
+              <a:rPr lang="en-US" sz="1100" b="1" spc="-50" kern="0" dirty="0">
+                <a:solidFill>
+                  <a:srgbClr val="1C1C1C"/>
+                </a:solidFill>
+                <a:latin typeface="Geist" pitchFamily="34" charset="0"/>
+                <a:ea typeface="Geist" pitchFamily="34" charset="-122"/>
+                <a:cs typeface="Geist" pitchFamily="34" charset="-120"/>
+              </a:rPr>
+              <a:t>Human-in-the-loop</a:t>
+            </a:r>
+            <a:endParaRPr lang="en-US" sz="1100" dirty="0"/>
+          </a:p>
+        </p:txBody>
+      </p:sp>
+      <p:sp>
+        <p:nvSpPr>
+          <p:cNvPr id="35" name="Text 32"/>
+          <p:cNvSpPr txBox="1"/>
+          <p:nvPr/>
+        </p:nvSpPr>
+        <p:spPr>
+          <a:xfrm>
+            <a:off x="5760720" y="3776472"/>
+            <a:ext cx="2926080" cy="384048"/>
+          </a:xfrm>
+          <a:prstGeom prst="rect">
+            <a:avLst/>
+          </a:prstGeom>
+          <a:noFill/>
+          <a:ln/>
+        </p:spPr>
+        <p:txBody>
+          <a:bodyPr wrap="square" lIns="0" tIns="0" rIns="0" bIns="0" rtlCol="0" anchor="t"/>
+          <a:lstStyle/>
+          <a:p>
+            <a:pPr indent="0" marL="0">
+              <a:buNone/>
+            </a:pPr>
+            <a:r>
+              <a:rPr lang="en-US" sz="850" dirty="0">
+                <a:solidFill>
+                  <a:srgbClr val="6B7280"/>
+                </a:solidFill>
+                <a:latin typeface="Geist" pitchFamily="34" charset="0"/>
+                <a:ea typeface="Geist" pitchFamily="34" charset="-122"/>
+                <a:cs typeface="Geist" pitchFamily="34" charset="-120"/>
+              </a:rPr>
+              <a:t>pause on irreversible or high-value actions, with full context attached</a:t>
+            </a:r>
+            <a:endParaRPr lang="en-US" sz="850" dirty="0"/>
+          </a:p>
+        </p:txBody>
+      </p:sp>
+      <p:sp>
+        <p:nvSpPr>
+          <p:cNvPr id="36" name="Shape 33"/>
+          <p:cNvSpPr/>
+          <p:nvPr/>
+        </p:nvSpPr>
+        <p:spPr>
+          <a:xfrm>
+            <a:off x="457200" y="4206240"/>
+            <a:ext cx="8229600" cy="457200"/>
+          </a:xfrm>
+          <a:prstGeom prst="rect">
+            <a:avLst/>
+          </a:prstGeom>
+          <a:solidFill>
+            <a:srgbClr val="F7F7F5"/>
+          </a:solidFill>
+          <a:ln w="9525">
+            <a:solidFill>
+              <a:srgbClr val="E5E5E5"/>
+            </a:solidFill>
+            <a:prstDash val="solid"/>
+          </a:ln>
+        </p:spPr>
+      </p:sp>
+      <p:sp>
+        <p:nvSpPr>
+          <p:cNvPr id="37" name="Text 34"/>
+          <p:cNvSpPr txBox="1"/>
+          <p:nvPr/>
+        </p:nvSpPr>
+        <p:spPr>
+          <a:xfrm>
+            <a:off x="685800" y="4206240"/>
+            <a:ext cx="7772400" cy="457200"/>
+          </a:xfrm>
+          <a:prstGeom prst="rect">
+            <a:avLst/>
+          </a:prstGeom>
+          <a:noFill/>
+          <a:ln/>
+        </p:spPr>
+        <p:txBody>
+          <a:bodyPr wrap="square" lIns="0" tIns="0" rIns="0" bIns="0" rtlCol="0" anchor="ctr"/>
+          <a:lstStyle/>
+          <a:p>
+            <a:pPr indent="0" marL="0">
+              <a:buNone/>
+            </a:pPr>
+            <a:r>
+              <a:rPr lang="en-US" sz="900" spc="200" kern="0" dirty="0">
+                <a:solidFill>
+                  <a:srgbClr val="FF5700"/>
+                </a:solidFill>
+                <a:latin typeface="IBM Plex Mono" pitchFamily="34" charset="0"/>
+                <a:ea typeface="IBM Plex Mono" pitchFamily="34" charset="-122"/>
+                <a:cs typeface="IBM Plex Mono" pitchFamily="34" charset="-120"/>
+              </a:rPr>
+              <a:t>RULE  </a:t>
+            </a:r>
+            <a:pPr indent="0" marL="0">
+              <a:buNone/>
+            </a:pPr>
+            <a:r>
+              <a:rPr lang="en-US" sz="1150" dirty="0">
+                <a:solidFill>
+                  <a:srgbClr val="1C1C1C"/>
+                </a:solidFill>
+                <a:latin typeface="Geist" pitchFamily="34" charset="0"/>
+                <a:ea typeface="Geist" pitchFamily="34" charset="-122"/>
+                <a:cs typeface="Geist" pitchFamily="34" charset="-120"/>
+              </a:rPr>
+              <a:t>a policy says what it should do; a guardrail makes sure it can't do otherwise. Write both — never rely on the prompt alone. Episode 25 builds the full set.</a:t>
+            </a:r>
+            <a:endParaRPr lang="en-US" sz="900" dirty="0"/>
+          </a:p>
+        </p:txBody>
+      </p:sp>
+    </p:spTree>
+  </p:cSld>
+  <p:clrMapOvr>
+    <a:masterClrMapping/>
+  </p:clrMapOvr>
+</p:sld>
+</file>
+
+<file path=ppt/slides/slide15.xml><?xml version="1.0" encoding="utf-8"?>
+<p:sld xmlns:a="http://schemas.openxmlformats.org/drawingml/2006/main" xmlns:r="http://schemas.openxmlformats.org/officeDocument/2006/relationships" xmlns:p="http://schemas.openxmlformats.org/presentationml/2006/main">
+  <p:cSld name="Slide 15">
+    <p:bg>
+      <p:bgPr>
+        <a:blipFill dpi="0" rotWithShape="1">
+          <a:blip r:embed="rId1">
+            <a:lum/>
+          </a:blip>
+          <a:srcRect/>
+          <a:stretch>
+            <a:fillRect/>
+          </a:stretch>
+        </a:blipFill>
+        <a:effectLst/>
+      </p:bgPr>
+    </p:bg>
+    <p:spTree>
+      <p:nvGrpSpPr>
+        <p:cNvPr id="1" name=""/>
+        <p:cNvGrpSpPr/>
+        <p:nvPr/>
+      </p:nvGrpSpPr>
+      <p:grpSpPr>
+        <a:xfrm>
+          <a:off x="0" y="0"/>
+          <a:ext cx="0" cy="0"/>
+          <a:chOff x="0" y="0"/>
+          <a:chExt cx="0" cy="0"/>
+        </a:xfrm>
+      </p:grpSpPr>
+      <p:sp>
+        <p:nvSpPr>
+          <p:cNvPr id="3" name="Text 0"/>
+          <p:cNvSpPr txBox="1"/>
+          <p:nvPr/>
+        </p:nvSpPr>
+        <p:spPr>
+          <a:xfrm>
             <a:off x="548640" y="384048"/>
             <a:ext cx="8229600" cy="320040"/>
           </a:xfrm>

</xml_diff>